<commit_message>
Changed a bit at home. 17 slides total target, modeling of EDL is main: detailed Poisson in multilayers + Vt calculation optimization by determinants.
</commit_message>
<xml_diff>
--- a/실력인품태도.pptx
+++ b/실력인품태도.pptx
@@ -115,7 +115,7 @@
             <a:srgbClr val="A4A3A4"/>
           </p15:clr>
         </p15:guide>
-        <p15:guide id="2" pos="2880">
+        <p15:guide id="2" pos="2857" userDrawn="1">
           <p15:clr>
             <a:srgbClr val="A4A3A4"/>
           </p15:clr>
@@ -4539,7 +4539,7 @@
         </p:nvSpPr>
         <p:spPr>
           <a:xfrm>
-            <a:off x="443060" y="4468306"/>
+            <a:off x="443060" y="4278699"/>
             <a:ext cx="2422688" cy="400110"/>
           </a:xfrm>
           <a:prstGeom prst="rect">
@@ -4586,7 +4586,7 @@
         <p:spPr>
           <a:xfrm>
             <a:off x="612743" y="762513"/>
-            <a:ext cx="2422688" cy="400110"/>
+            <a:ext cx="7666018" cy="1323439"/>
           </a:xfrm>
           <a:prstGeom prst="rect">
             <a:avLst/>
@@ -4599,21 +4599,249 @@
           </a:bodyPr>
           <a:lstStyle/>
           <a:p>
-            <a:r>
-              <a:rPr lang="ko-KR" altLang="en-US" sz="2000" dirty="0">
-                <a:ln w="9525">
-                  <a:solidFill>
-                    <a:schemeClr val="tx1">
-                      <a:alpha val="29000"/>
-                    </a:schemeClr>
-                  </a:solidFill>
-                </a:ln>
-                <a:latin typeface="Times New Roman"/>
-                <a:ea typeface="맑은 고딕"/>
-                <a:cs typeface="Times New Roman"/>
-              </a:rPr>
-              <a:t>실력</a:t>
-            </a:r>
+            <a:pPr marL="342900" indent="-342900">
+              <a:buFont typeface="Arial" panose="020B0604020202020204" pitchFamily="34" charset="0"/>
+              <a:buChar char="•"/>
+            </a:pPr>
+            <a:r>
+              <a:rPr lang="ko-KR" altLang="ko-KR" sz="2000" dirty="0"/>
+              <a:t>3-D NAND </a:t>
+            </a:r>
+            <a:r>
+              <a:rPr lang="ko-KR" altLang="ko-KR" sz="2000" dirty="0" err="1"/>
+              <a:t>Flash</a:t>
+            </a:r>
+            <a:r>
+              <a:rPr lang="ko-KR" altLang="ko-KR" sz="2000" dirty="0"/>
+              <a:t> </a:t>
+            </a:r>
+            <a:r>
+              <a:rPr lang="ko-KR" altLang="ko-KR" sz="2000" dirty="0" err="1"/>
+              <a:t>retention</a:t>
+            </a:r>
+            <a:r>
+              <a:rPr lang="ko-KR" altLang="ko-KR" sz="2000" dirty="0"/>
+              <a:t> </a:t>
+            </a:r>
+            <a:r>
+              <a:rPr lang="ko-KR" altLang="ko-KR" sz="2000" dirty="0" err="1"/>
+              <a:t>modeling</a:t>
+            </a:r>
+            <a:r>
+              <a:rPr lang="ko-KR" altLang="ko-KR" sz="2000" dirty="0"/>
+              <a:t> 연구를 수행하여 IEEE TED 및 IEEE </a:t>
+            </a:r>
+            <a:r>
+              <a:rPr lang="ko-KR" altLang="ko-KR" sz="2000" dirty="0" err="1"/>
+              <a:t>EDL에</a:t>
+            </a:r>
+            <a:r>
+              <a:rPr lang="ko-KR" altLang="ko-KR" sz="2000" dirty="0"/>
+              <a:t> 각각 </a:t>
+            </a:r>
+            <a:r>
+              <a:rPr lang="ko-KR" altLang="ko-KR" sz="2000" dirty="0" err="1"/>
+              <a:t>투고·게재함</a:t>
+            </a:r>
+            <a:r>
+              <a:rPr lang="ko-KR" altLang="ko-KR" sz="2000" dirty="0"/>
+              <a:t>.</a:t>
+            </a:r>
+            <a:endParaRPr lang="en-US" altLang="ko-KR" sz="2000" dirty="0"/>
+          </a:p>
+          <a:p>
+            <a:pPr marL="342900" indent="-342900">
+              <a:buFont typeface="Arial" panose="020B0604020202020204" pitchFamily="34" charset="0"/>
+              <a:buChar char="•"/>
+            </a:pPr>
+            <a:r>
+              <a:rPr lang="ko-KR" altLang="ko-KR" sz="2000" dirty="0"/>
+              <a:t>TCAD </a:t>
+            </a:r>
+            <a:r>
+              <a:rPr lang="ko-KR" altLang="ko-KR" sz="2000" dirty="0" err="1"/>
+              <a:t>simulation</a:t>
+            </a:r>
+            <a:r>
+              <a:rPr lang="ko-KR" altLang="ko-KR" sz="2000" dirty="0"/>
+              <a:t>, </a:t>
+            </a:r>
+            <a:r>
+              <a:rPr lang="ko-KR" altLang="ko-KR" sz="2000" dirty="0" err="1"/>
+              <a:t>analytical</a:t>
+            </a:r>
+            <a:r>
+              <a:rPr lang="ko-KR" altLang="ko-KR" sz="2000" dirty="0"/>
+              <a:t> </a:t>
+            </a:r>
+            <a:r>
+              <a:rPr lang="ko-KR" altLang="ko-KR" sz="2000" dirty="0" err="1"/>
+              <a:t>modeling</a:t>
+            </a:r>
+            <a:r>
+              <a:rPr lang="ko-KR" altLang="ko-KR" sz="2000" dirty="0"/>
+              <a:t>, </a:t>
+            </a:r>
+            <a:r>
+              <a:rPr lang="ko-KR" altLang="ko-KR" sz="2000" dirty="0" err="1"/>
+              <a:t>device</a:t>
+            </a:r>
+            <a:r>
+              <a:rPr lang="ko-KR" altLang="ko-KR" sz="2000" dirty="0"/>
+              <a:t> </a:t>
+            </a:r>
+            <a:r>
+              <a:rPr lang="ko-KR" altLang="ko-KR" sz="2000" dirty="0" err="1"/>
+              <a:t>physics</a:t>
+            </a:r>
+            <a:r>
+              <a:rPr lang="ko-KR" altLang="ko-KR" sz="2000" dirty="0"/>
+              <a:t> 해석을 연결하여 물리 기반 모델링 역량을 입증함.</a:t>
+            </a:r>
+            <a:endParaRPr lang="ko-KR" altLang="en-US" sz="2000" dirty="0">
+              <a:ln w="9525">
+                <a:solidFill>
+                  <a:schemeClr val="tx1">
+                    <a:alpha val="29000"/>
+                  </a:schemeClr>
+                </a:solidFill>
+              </a:ln>
+              <a:latin typeface="Times New Roman"/>
+              <a:ea typeface="맑은 고딕"/>
+              <a:cs typeface="Times New Roman"/>
+            </a:endParaRPr>
+          </a:p>
+        </p:txBody>
+      </p:sp>
+      <p:sp>
+        <p:nvSpPr>
+          <p:cNvPr id="7" name="TextBox 6">
+            <a:extLst>
+              <a:ext uri="{FF2B5EF4-FFF2-40B4-BE49-F238E27FC236}">
+                <a16:creationId xmlns:a16="http://schemas.microsoft.com/office/drawing/2014/main" id="{FB68BF02-80B1-1779-BBEF-1571982DA553}"/>
+              </a:ext>
+            </a:extLst>
+          </p:cNvPr>
+          <p:cNvSpPr txBox="1"/>
+          <p:nvPr/>
+        </p:nvSpPr>
+        <p:spPr>
+          <a:xfrm>
+            <a:off x="612743" y="2720661"/>
+            <a:ext cx="7666018" cy="1323439"/>
+          </a:xfrm>
+          <a:prstGeom prst="rect">
+            <a:avLst/>
+          </a:prstGeom>
+          <a:noFill/>
+        </p:spPr>
+        <p:txBody>
+          <a:bodyPr wrap="square" rtlCol="0">
+            <a:spAutoFit/>
+          </a:bodyPr>
+          <a:lstStyle/>
+          <a:p>
+            <a:pPr marL="342900" indent="-342900">
+              <a:buFont typeface="Arial" panose="020B0604020202020204" pitchFamily="34" charset="0"/>
+              <a:buChar char="•"/>
+            </a:pPr>
+            <a:r>
+              <a:rPr lang="ko-KR" altLang="ko-KR" sz="2000" dirty="0"/>
+              <a:t>개인의 성과보다 연구실의 방향과 공동체의 지속성을 우선하는 자세로 생활함.</a:t>
+            </a:r>
+            <a:endParaRPr lang="en-US" altLang="ko-KR" sz="2000" dirty="0"/>
+          </a:p>
+          <a:p>
+            <a:pPr marL="342900" indent="-342900">
+              <a:buFont typeface="Arial" panose="020B0604020202020204" pitchFamily="34" charset="0"/>
+              <a:buChar char="•"/>
+            </a:pPr>
+            <a:r>
+              <a:rPr lang="ko-KR" altLang="ko-KR" sz="2000" dirty="0"/>
+              <a:t>연구실 업무, 자료, 경험을 성실히 공유하고 인수인계 이후의 후속 질문에도 책임 있게 대응함.</a:t>
+            </a:r>
+            <a:endParaRPr lang="ko-KR" altLang="en-US" sz="2000" dirty="0">
+              <a:ln w="9525">
+                <a:solidFill>
+                  <a:schemeClr val="tx1">
+                    <a:alpha val="29000"/>
+                  </a:schemeClr>
+                </a:solidFill>
+              </a:ln>
+              <a:latin typeface="Times New Roman"/>
+              <a:ea typeface="맑은 고딕"/>
+              <a:cs typeface="Times New Roman"/>
+            </a:endParaRPr>
+          </a:p>
+        </p:txBody>
+      </p:sp>
+      <p:sp>
+        <p:nvSpPr>
+          <p:cNvPr id="8" name="TextBox 7">
+            <a:extLst>
+              <a:ext uri="{FF2B5EF4-FFF2-40B4-BE49-F238E27FC236}">
+                <a16:creationId xmlns:a16="http://schemas.microsoft.com/office/drawing/2014/main" id="{DF2A08EA-D9EA-89C8-ADFA-76A57C7488FD}"/>
+              </a:ext>
+            </a:extLst>
+          </p:cNvPr>
+          <p:cNvSpPr txBox="1"/>
+          <p:nvPr/>
+        </p:nvSpPr>
+        <p:spPr>
+          <a:xfrm>
+            <a:off x="612743" y="4804587"/>
+            <a:ext cx="7666018" cy="1323439"/>
+          </a:xfrm>
+          <a:prstGeom prst="rect">
+            <a:avLst/>
+          </a:prstGeom>
+          <a:noFill/>
+        </p:spPr>
+        <p:txBody>
+          <a:bodyPr wrap="square" rtlCol="0">
+            <a:spAutoFit/>
+          </a:bodyPr>
+          <a:lstStyle/>
+          <a:p>
+            <a:pPr marL="342900" indent="-342900">
+              <a:buFont typeface="Arial" panose="020B0604020202020204" pitchFamily="34" charset="0"/>
+              <a:buChar char="•"/>
+            </a:pPr>
+            <a:r>
+              <a:rPr lang="ko-KR" altLang="ko-KR" sz="2000" dirty="0"/>
+              <a:t>학업과 진로에 대한 고민 속에서도 맡은 역할과 특성화대학 사업을 끝까지 수행하려는 태도를 유지함.</a:t>
+            </a:r>
+            <a:endParaRPr lang="en-US" altLang="ko-KR" sz="2000" dirty="0"/>
+          </a:p>
+          <a:p>
+            <a:pPr marL="342900" indent="-342900">
+              <a:buFont typeface="Arial" panose="020B0604020202020204" pitchFamily="34" charset="0"/>
+              <a:buChar char="•"/>
+            </a:pPr>
+            <a:r>
+              <a:rPr lang="ko-KR" altLang="ko-KR" sz="2000" dirty="0"/>
+              <a:t>단순한 결과 </a:t>
+            </a:r>
+            <a:r>
+              <a:rPr lang="ko-KR" altLang="ko-KR" sz="2000" dirty="0" err="1"/>
+              <a:t>fitting보다</a:t>
+            </a:r>
+            <a:r>
+              <a:rPr lang="ko-KR" altLang="ko-KR" sz="2000" dirty="0"/>
+              <a:t> 물리적 근거와 설명 가능성을 중시하며 연구 방향을 원칙 있게 정립함.</a:t>
+            </a:r>
+            <a:endParaRPr lang="ko-KR" altLang="en-US" sz="2000" dirty="0">
+              <a:ln w="9525">
+                <a:solidFill>
+                  <a:schemeClr val="tx1">
+                    <a:alpha val="29000"/>
+                  </a:schemeClr>
+                </a:solidFill>
+              </a:ln>
+              <a:latin typeface="Times New Roman"/>
+              <a:ea typeface="맑은 고딕"/>
+              <a:cs typeface="Times New Roman"/>
+            </a:endParaRPr>
           </a:p>
         </p:txBody>
       </p:sp>

</xml_diff>

<commit_message>
Master degree graduation presentation file finished in first manuscript.
</commit_message>
<xml_diff>
--- a/실력인품태도.pptx
+++ b/실력인품태도.pptx
@@ -5,10 +5,13 @@
     <p:sldMasterId id="2147483672" r:id="rId1"/>
   </p:sldMasterIdLst>
   <p:notesMasterIdLst>
-    <p:notesMasterId r:id="rId3"/>
+    <p:notesMasterId r:id="rId6"/>
   </p:notesMasterIdLst>
   <p:sldIdLst>
-    <p:sldId id="315" r:id="rId2"/>
+    <p:sldId id="318" r:id="rId2"/>
+    <p:sldId id="315" r:id="rId3"/>
+    <p:sldId id="316" r:id="rId4"/>
+    <p:sldId id="317" r:id="rId5"/>
   </p:sldIdLst>
   <p:sldSz cx="9144000" cy="6858000" type="screen4x3"/>
   <p:notesSz cx="6858000" cy="9144000"/>
@@ -220,7 +223,7 @@
               <a:pPr lvl="0">
                 <a:defRPr/>
               </a:pPr>
-              <a:t>2026-07-06</a:t>
+              <a:t>2026-07-08</a:t>
             </a:fld>
             <a:endParaRPr lang="ko-KR" altLang="en-US"/>
           </a:p>
@@ -830,7 +833,7 @@
           <a:p>
             <a:fld id="{B3B0509C-DF52-4D9E-B08B-80FF4BADBE5B}" type="datetime1">
               <a:rPr lang="ko-KR" altLang="en-US" smtClean="0"/>
-              <a:t>2026-07-06</a:t>
+              <a:t>2026-07-08</a:t>
             </a:fld>
             <a:endParaRPr lang="ko-KR" altLang="en-US"/>
           </a:p>
@@ -1120,7 +1123,7 @@
           <a:p>
             <a:fld id="{D7E32654-65AB-44C2-B15A-24814E9FAC6C}" type="datetime1">
               <a:rPr lang="ko-KR" altLang="en-US" smtClean="0"/>
-              <a:t>2026-07-06</a:t>
+              <a:t>2026-07-08</a:t>
             </a:fld>
             <a:endParaRPr lang="ko-KR" altLang="en-US"/>
           </a:p>
@@ -1330,7 +1333,7 @@
           <a:p>
             <a:fld id="{8A4443EB-2E16-4E63-8781-456863843F67}" type="datetime1">
               <a:rPr lang="ko-KR" altLang="en-US" smtClean="0"/>
-              <a:t>2026-07-06</a:t>
+              <a:t>2026-07-08</a:t>
             </a:fld>
             <a:endParaRPr lang="ko-KR" altLang="en-US"/>
           </a:p>
@@ -1540,7 +1543,7 @@
           <a:p>
             <a:fld id="{C33B04AE-6A3D-446A-BA2E-D60D9DF7E98F}" type="datetime1">
               <a:rPr lang="ko-KR" altLang="en-US" smtClean="0"/>
-              <a:t>2026-07-06</a:t>
+              <a:t>2026-07-08</a:t>
             </a:fld>
             <a:endParaRPr lang="ko-KR" altLang="en-US"/>
           </a:p>
@@ -1701,7 +1704,7 @@
           <a:p>
             <a:fld id="{DDA8C695-F3F3-4DFA-BE8E-F96FA1E20C9A}" type="datetime1">
               <a:rPr lang="ko-KR" altLang="en-US" smtClean="0"/>
-              <a:t>2026-07-06</a:t>
+              <a:t>2026-07-08</a:t>
             </a:fld>
             <a:endParaRPr lang="ko-KR" altLang="en-US"/>
           </a:p>
@@ -2822,7 +2825,7 @@
           <a:p>
             <a:fld id="{34A334C5-B9FA-4ED1-A744-F408B6777B24}" type="datetime1">
               <a:rPr lang="ko-KR" altLang="en-US" smtClean="0"/>
-              <a:t>2026-07-06</a:t>
+              <a:t>2026-07-08</a:t>
             </a:fld>
             <a:endParaRPr lang="ko-KR" altLang="en-US"/>
           </a:p>
@@ -3092,7 +3095,7 @@
           <a:p>
             <a:fld id="{9E5042A7-DF43-46DE-92FC-CFB97544BBB3}" type="datetime1">
               <a:rPr lang="ko-KR" altLang="en-US" smtClean="0"/>
-              <a:t>2026-07-06</a:t>
+              <a:t>2026-07-08</a:t>
             </a:fld>
             <a:endParaRPr lang="ko-KR" altLang="en-US"/>
           </a:p>
@@ -3498,7 +3501,7 @@
           <a:p>
             <a:fld id="{2916D5AD-5A6F-454C-9545-6885344E280D}" type="datetime1">
               <a:rPr lang="ko-KR" altLang="en-US" smtClean="0"/>
-              <a:t>2026-07-06</a:t>
+              <a:t>2026-07-08</a:t>
             </a:fld>
             <a:endParaRPr lang="ko-KR" altLang="en-US"/>
           </a:p>
@@ -3648,7 +3651,7 @@
           <a:p>
             <a:fld id="{13F7BB00-28E5-4A3B-9E5F-1F4BB3A8F165}" type="datetime1">
               <a:rPr lang="ko-KR" altLang="en-US" smtClean="0"/>
-              <a:t>2026-07-06</a:t>
+              <a:t>2026-07-08</a:t>
             </a:fld>
             <a:endParaRPr lang="ko-KR" altLang="en-US"/>
           </a:p>
@@ -3767,7 +3770,7 @@
           <a:p>
             <a:fld id="{2CEAC59B-C817-48F5-8ACE-D9D17C2470A4}" type="datetime1">
               <a:rPr lang="ko-KR" altLang="en-US" smtClean="0"/>
-              <a:t>2026-07-06</a:t>
+              <a:t>2026-07-08</a:t>
             </a:fld>
             <a:endParaRPr lang="ko-KR" altLang="en-US"/>
           </a:p>
@@ -4394,6 +4397,89 @@
       </p:grpSpPr>
       <p:sp>
         <p:nvSpPr>
+          <p:cNvPr id="2" name="제목 1">
+            <a:extLst>
+              <a:ext uri="{FF2B5EF4-FFF2-40B4-BE49-F238E27FC236}">
+                <a16:creationId xmlns:a16="http://schemas.microsoft.com/office/drawing/2014/main" id="{E6A48431-DCB5-1D39-91B8-EC90D94105B1}"/>
+              </a:ext>
+            </a:extLst>
+          </p:cNvPr>
+          <p:cNvSpPr>
+            <a:spLocks noGrp="1"/>
+          </p:cNvSpPr>
+          <p:nvPr>
+            <p:ph type="title"/>
+          </p:nvPr>
+        </p:nvSpPr>
+        <p:spPr/>
+        <p:txBody>
+          <a:bodyPr/>
+          <a:lstStyle/>
+          <a:p>
+            <a:r>
+              <a:rPr lang="ko-KR" altLang="en-US" dirty="0"/>
+              <a:t>인품</a:t>
+            </a:r>
+            <a:r>
+              <a:rPr lang="en-US" altLang="ko-KR" dirty="0"/>
+              <a:t>, </a:t>
+            </a:r>
+            <a:r>
+              <a:rPr lang="ko-KR" altLang="en-US" dirty="0"/>
+              <a:t>태도 및 실력</a:t>
+            </a:r>
+            <a:br>
+              <a:rPr lang="en-US" altLang="ko-KR" dirty="0"/>
+            </a:br>
+            <a:r>
+              <a:rPr lang="ko-KR" altLang="en-US" dirty="0"/>
+              <a:t>자체평가서</a:t>
+            </a:r>
+            <a:br>
+              <a:rPr lang="en-US" altLang="ko-KR" dirty="0"/>
+            </a:br>
+            <a:br>
+              <a:rPr lang="en-US" altLang="ko-KR" dirty="0"/>
+            </a:br>
+            <a:r>
+              <a:rPr lang="ko-KR" altLang="en-US" dirty="0"/>
+              <a:t>진명</a:t>
+            </a:r>
+          </a:p>
+        </p:txBody>
+      </p:sp>
+    </p:spTree>
+    <p:extLst>
+      <p:ext uri="{BB962C8B-B14F-4D97-AF65-F5344CB8AC3E}">
+        <p14:creationId xmlns:p14="http://schemas.microsoft.com/office/powerpoint/2010/main" val="3861834395"/>
+      </p:ext>
+    </p:extLst>
+  </p:cSld>
+  <p:clrMapOvr>
+    <a:masterClrMapping/>
+  </p:clrMapOvr>
+</p:sld>
+</file>
+
+<file path=ppt/slides/slide2.xml><?xml version="1.0" encoding="utf-8"?>
+<p:sld xmlns:a="http://schemas.openxmlformats.org/drawingml/2006/main" xmlns:r="http://schemas.openxmlformats.org/officeDocument/2006/relationships" xmlns:p="http://schemas.openxmlformats.org/presentationml/2006/main">
+  <p:cSld>
+    <p:spTree>
+      <p:nvGrpSpPr>
+        <p:cNvPr id="1" name=""/>
+        <p:cNvGrpSpPr/>
+        <p:nvPr/>
+      </p:nvGrpSpPr>
+      <p:grpSpPr>
+        <a:xfrm>
+          <a:off x="0" y="0"/>
+          <a:ext cx="0" cy="0"/>
+          <a:chOff x="0" y="0"/>
+          <a:chExt cx="0" cy="0"/>
+        </a:xfrm>
+      </p:grpSpPr>
+      <p:sp>
+        <p:nvSpPr>
           <p:cNvPr id="2" name="슬라이드 번호 개체 틀 1">
             <a:extLst>
               <a:ext uri="{FF2B5EF4-FFF2-40B4-BE49-F238E27FC236}">
@@ -4415,7 +4501,7 @@
           <a:p>
             <a:fld id="{1F989CB1-DA8A-44BB-A4A9-D7F9352F01ED}" type="slidenum">
               <a:rPr lang="ko-KR" altLang="en-US" smtClean="0"/>
-              <a:t>0</a:t>
+              <a:t>1</a:t>
             </a:fld>
             <a:endParaRPr lang="ko-KR" altLang="en-US"/>
           </a:p>
@@ -4436,7 +4522,7 @@
         <p:spPr>
           <a:xfrm>
             <a:off x="443060" y="348792"/>
-            <a:ext cx="2422688" cy="400110"/>
+            <a:ext cx="2422688" cy="523220"/>
           </a:xfrm>
           <a:prstGeom prst="rect">
             <a:avLst/>
@@ -4450,7 +4536,7 @@
           <a:lstStyle/>
           <a:p>
             <a:r>
-              <a:rPr lang="ko-KR" altLang="en-US" sz="2000">
+              <a:rPr lang="ko-KR" altLang="en-US" sz="2800" dirty="0">
                 <a:ln w="9525">
                   <a:solidFill>
                     <a:schemeClr val="tx1">
@@ -4481,10 +4567,10 @@
       </p:sp>
       <p:sp>
         <p:nvSpPr>
-          <p:cNvPr id="4" name="TextBox 3">
+          <p:cNvPr id="6" name="TextBox 5">
             <a:extLst>
               <a:ext uri="{FF2B5EF4-FFF2-40B4-BE49-F238E27FC236}">
-                <a16:creationId xmlns:a16="http://schemas.microsoft.com/office/drawing/2014/main" id="{D2E4C913-BBE8-944F-102A-F25ABC7CBB87}"/>
+                <a16:creationId xmlns:a16="http://schemas.microsoft.com/office/drawing/2014/main" id="{3BEEDD9A-3FD1-99D1-1751-F98B519FFE36}"/>
               </a:ext>
             </a:extLst>
           </p:cNvPr>
@@ -4493,8 +4579,8 @@
         </p:nvSpPr>
         <p:spPr>
           <a:xfrm>
-            <a:off x="443060" y="2196446"/>
-            <a:ext cx="2422688" cy="400110"/>
+            <a:off x="612743" y="1329672"/>
+            <a:ext cx="7666018" cy="2862322"/>
           </a:xfrm>
           <a:prstGeom prst="rect">
             <a:avLst/>
@@ -4507,6 +4593,412 @@
           </a:bodyPr>
           <a:lstStyle/>
           <a:p>
+            <a:pPr marL="342900" indent="-342900">
+              <a:buFont typeface="Arial" panose="020B0604020202020204" pitchFamily="34" charset="0"/>
+              <a:buChar char="•"/>
+            </a:pPr>
+            <a:endParaRPr lang="en-US" altLang="ko-KR" sz="2000" dirty="0"/>
+          </a:p>
+          <a:p>
+            <a:pPr marL="342900" indent="-342900">
+              <a:buFont typeface="Arial" panose="020B0604020202020204" pitchFamily="34" charset="0"/>
+              <a:buChar char="•"/>
+            </a:pPr>
+            <a:endParaRPr lang="en-US" altLang="ko-KR" sz="2000" dirty="0"/>
+          </a:p>
+          <a:p>
+            <a:pPr marL="342900" indent="-342900">
+              <a:buFont typeface="Arial" panose="020B0604020202020204" pitchFamily="34" charset="0"/>
+              <a:buChar char="•"/>
+            </a:pPr>
+            <a:endParaRPr lang="en-US" altLang="ko-KR" sz="2000" dirty="0"/>
+          </a:p>
+          <a:p>
+            <a:pPr marL="342900" indent="-342900">
+              <a:buFont typeface="Arial" panose="020B0604020202020204" pitchFamily="34" charset="0"/>
+              <a:buChar char="•"/>
+            </a:pPr>
+            <a:endParaRPr lang="en-US" altLang="ko-KR" sz="2000" dirty="0"/>
+          </a:p>
+          <a:p>
+            <a:r>
+              <a:rPr lang="en-US" altLang="ko-KR" sz="2000" dirty="0"/>
+              <a:t>1</a:t>
+            </a:r>
+            <a:r>
+              <a:rPr lang="ko-KR" altLang="en-US" sz="2000" dirty="0"/>
+              <a:t>저자 논문 </a:t>
+            </a:r>
+            <a:r>
+              <a:rPr lang="en-US" altLang="ko-KR" sz="2000" dirty="0"/>
+              <a:t>2</a:t>
+            </a:r>
+            <a:r>
+              <a:rPr lang="ko-KR" altLang="en-US" sz="2000" dirty="0"/>
+              <a:t>편 </a:t>
+            </a:r>
+            <a:r>
+              <a:rPr lang="en-US" altLang="ko-KR" sz="2000" dirty="0"/>
+              <a:t>Publish (IEEE TED, E</a:t>
+            </a:r>
+            <a:r>
+              <a:rPr lang="ko-KR" altLang="en-US" sz="2000" dirty="0"/>
+              <a:t>이</a:t>
+            </a:r>
+            <a:r>
+              <a:rPr lang="en-US" altLang="ko-KR" sz="2000" dirty="0"/>
+              <a:t> </a:t>
+            </a:r>
+            <a:r>
+              <a:rPr lang="ko-KR" altLang="en-US" sz="2000" dirty="0"/>
+              <a:t>각 </a:t>
+            </a:r>
+            <a:r>
+              <a:rPr lang="en-US" altLang="ko-KR" sz="2000" dirty="0"/>
+              <a:t>1</a:t>
+            </a:r>
+            <a:r>
+              <a:rPr lang="ko-KR" altLang="en-US" sz="2000" dirty="0"/>
+              <a:t>편</a:t>
+            </a:r>
+            <a:r>
+              <a:rPr lang="en-US" altLang="ko-KR" sz="2000" dirty="0"/>
+              <a:t>)</a:t>
+            </a:r>
+          </a:p>
+          <a:p>
+            <a:pPr marL="342900" indent="-342900">
+              <a:buFont typeface="Arial" panose="020B0604020202020204" pitchFamily="34" charset="0"/>
+              <a:buChar char="•"/>
+            </a:pPr>
+            <a:r>
+              <a:rPr lang="ko-KR" altLang="ko-KR" sz="2000" dirty="0"/>
+              <a:t>3-D NAND </a:t>
+            </a:r>
+            <a:r>
+              <a:rPr lang="ko-KR" altLang="ko-KR" sz="2000" dirty="0" err="1"/>
+              <a:t>Flash</a:t>
+            </a:r>
+            <a:r>
+              <a:rPr lang="ko-KR" altLang="ko-KR" sz="2000" dirty="0"/>
+              <a:t> </a:t>
+            </a:r>
+            <a:r>
+              <a:rPr lang="ko-KR" altLang="ko-KR" sz="2000" dirty="0" err="1"/>
+              <a:t>retention</a:t>
+            </a:r>
+            <a:r>
+              <a:rPr lang="ko-KR" altLang="ko-KR" sz="2000" dirty="0"/>
+              <a:t> </a:t>
+            </a:r>
+            <a:r>
+              <a:rPr lang="ko-KR" altLang="ko-KR" sz="2000" dirty="0" err="1"/>
+              <a:t>modeling</a:t>
+            </a:r>
+            <a:r>
+              <a:rPr lang="ko-KR" altLang="ko-KR" sz="2000" dirty="0"/>
+              <a:t> 연구를 수행하여 IEEE TED 및 IEEE </a:t>
+            </a:r>
+            <a:r>
+              <a:rPr lang="ko-KR" altLang="ko-KR" sz="2000" dirty="0" err="1"/>
+              <a:t>EDL에</a:t>
+            </a:r>
+            <a:r>
+              <a:rPr lang="ko-KR" altLang="ko-KR" sz="2000" dirty="0"/>
+              <a:t> 각각 </a:t>
+            </a:r>
+            <a:r>
+              <a:rPr lang="ko-KR" altLang="ko-KR" sz="2000" dirty="0" err="1"/>
+              <a:t>투고·게재함</a:t>
+            </a:r>
+            <a:r>
+              <a:rPr lang="ko-KR" altLang="ko-KR" sz="2000" dirty="0"/>
+              <a:t>.</a:t>
+            </a:r>
+            <a:endParaRPr lang="en-US" altLang="ko-KR" sz="2000" dirty="0"/>
+          </a:p>
+          <a:p>
+            <a:pPr marL="342900" indent="-342900">
+              <a:buFont typeface="Arial" panose="020B0604020202020204" pitchFamily="34" charset="0"/>
+              <a:buChar char="•"/>
+            </a:pPr>
+            <a:r>
+              <a:rPr lang="ko-KR" altLang="ko-KR" sz="2000" dirty="0"/>
+              <a:t>TCAD </a:t>
+            </a:r>
+            <a:r>
+              <a:rPr lang="ko-KR" altLang="ko-KR" sz="2000" dirty="0" err="1"/>
+              <a:t>simulation</a:t>
+            </a:r>
+            <a:r>
+              <a:rPr lang="ko-KR" altLang="ko-KR" sz="2000" dirty="0"/>
+              <a:t>, </a:t>
+            </a:r>
+            <a:r>
+              <a:rPr lang="ko-KR" altLang="ko-KR" sz="2000" dirty="0" err="1"/>
+              <a:t>analytical</a:t>
+            </a:r>
+            <a:r>
+              <a:rPr lang="ko-KR" altLang="ko-KR" sz="2000" dirty="0"/>
+              <a:t> </a:t>
+            </a:r>
+            <a:r>
+              <a:rPr lang="ko-KR" altLang="ko-KR" sz="2000" dirty="0" err="1"/>
+              <a:t>modeling</a:t>
+            </a:r>
+            <a:r>
+              <a:rPr lang="ko-KR" altLang="ko-KR" sz="2000" dirty="0"/>
+              <a:t>, </a:t>
+            </a:r>
+            <a:r>
+              <a:rPr lang="ko-KR" altLang="ko-KR" sz="2000" dirty="0" err="1"/>
+              <a:t>device</a:t>
+            </a:r>
+            <a:r>
+              <a:rPr lang="ko-KR" altLang="ko-KR" sz="2000" dirty="0"/>
+              <a:t> </a:t>
+            </a:r>
+            <a:r>
+              <a:rPr lang="ko-KR" altLang="ko-KR" sz="2000" dirty="0" err="1"/>
+              <a:t>physics</a:t>
+            </a:r>
+            <a:r>
+              <a:rPr lang="ko-KR" altLang="ko-KR" sz="2000" dirty="0"/>
+              <a:t> 해석을 연결하여 물리 기반 모델링 역량을 입증함.</a:t>
+            </a:r>
+            <a:endParaRPr lang="ko-KR" altLang="en-US" sz="2000" dirty="0">
+              <a:ln w="9525">
+                <a:solidFill>
+                  <a:schemeClr val="tx1">
+                    <a:alpha val="29000"/>
+                  </a:schemeClr>
+                </a:solidFill>
+              </a:ln>
+              <a:latin typeface="Times New Roman"/>
+              <a:ea typeface="맑은 고딕"/>
+              <a:cs typeface="Times New Roman"/>
+            </a:endParaRPr>
+          </a:p>
+        </p:txBody>
+      </p:sp>
+    </p:spTree>
+    <p:extLst>
+      <p:ext uri="{BB962C8B-B14F-4D97-AF65-F5344CB8AC3E}">
+        <p14:creationId xmlns:p14="http://schemas.microsoft.com/office/powerpoint/2010/main" val="2735875424"/>
+      </p:ext>
+    </p:extLst>
+  </p:cSld>
+  <p:clrMapOvr>
+    <a:masterClrMapping/>
+  </p:clrMapOvr>
+</p:sld>
+</file>
+
+<file path=ppt/slides/slide3.xml><?xml version="1.0" encoding="utf-8"?>
+<p:sld xmlns:a="http://schemas.openxmlformats.org/drawingml/2006/main" xmlns:r="http://schemas.openxmlformats.org/officeDocument/2006/relationships" xmlns:p="http://schemas.openxmlformats.org/presentationml/2006/main">
+  <p:cSld>
+    <p:spTree>
+      <p:nvGrpSpPr>
+        <p:cNvPr id="1" name="">
+          <a:extLst>
+            <a:ext uri="{FF2B5EF4-FFF2-40B4-BE49-F238E27FC236}">
+              <a16:creationId xmlns:a16="http://schemas.microsoft.com/office/drawing/2014/main" id="{AC763EAA-5D0F-1201-642E-D432FCF0F730}"/>
+            </a:ext>
+          </a:extLst>
+        </p:cNvPr>
+        <p:cNvGrpSpPr/>
+        <p:nvPr/>
+      </p:nvGrpSpPr>
+      <p:grpSpPr>
+        <a:xfrm>
+          <a:off x="0" y="0"/>
+          <a:ext cx="0" cy="0"/>
+          <a:chOff x="0" y="0"/>
+          <a:chExt cx="0" cy="0"/>
+        </a:xfrm>
+      </p:grpSpPr>
+      <p:sp>
+        <p:nvSpPr>
+          <p:cNvPr id="2" name="슬라이드 번호 개체 틀 1">
+            <a:extLst>
+              <a:ext uri="{FF2B5EF4-FFF2-40B4-BE49-F238E27FC236}">
+                <a16:creationId xmlns:a16="http://schemas.microsoft.com/office/drawing/2014/main" id="{4E1F9EFE-5C4B-2FC3-B605-F10267EC84A4}"/>
+              </a:ext>
+            </a:extLst>
+          </p:cNvPr>
+          <p:cNvSpPr>
+            <a:spLocks noGrp="1"/>
+          </p:cNvSpPr>
+          <p:nvPr>
+            <p:ph type="sldNum" sz="quarter" idx="12"/>
+          </p:nvPr>
+        </p:nvSpPr>
+        <p:spPr/>
+        <p:txBody>
+          <a:bodyPr/>
+          <a:lstStyle/>
+          <a:p>
+            <a:fld id="{1F989CB1-DA8A-44BB-A4A9-D7F9352F01ED}" type="slidenum">
+              <a:rPr lang="ko-KR" altLang="en-US" smtClean="0"/>
+              <a:t>2</a:t>
+            </a:fld>
+            <a:endParaRPr lang="ko-KR" altLang="en-US"/>
+          </a:p>
+        </p:txBody>
+      </p:sp>
+      <p:sp>
+        <p:nvSpPr>
+          <p:cNvPr id="3" name="TextBox 2">
+            <a:extLst>
+              <a:ext uri="{FF2B5EF4-FFF2-40B4-BE49-F238E27FC236}">
+                <a16:creationId xmlns:a16="http://schemas.microsoft.com/office/drawing/2014/main" id="{6E58F976-1ED0-4506-11BB-097DFE12539C}"/>
+              </a:ext>
+            </a:extLst>
+          </p:cNvPr>
+          <p:cNvSpPr txBox="1"/>
+          <p:nvPr/>
+        </p:nvSpPr>
+        <p:spPr>
+          <a:xfrm>
+            <a:off x="443060" y="348792"/>
+            <a:ext cx="2422688" cy="523220"/>
+          </a:xfrm>
+          <a:prstGeom prst="rect">
+            <a:avLst/>
+          </a:prstGeom>
+          <a:noFill/>
+        </p:spPr>
+        <p:txBody>
+          <a:bodyPr wrap="square" rtlCol="0">
+            <a:spAutoFit/>
+          </a:bodyPr>
+          <a:lstStyle/>
+          <a:p>
+            <a:r>
+              <a:rPr lang="ko-KR" altLang="en-US" sz="2800" dirty="0">
+                <a:ln w="9525">
+                  <a:solidFill>
+                    <a:schemeClr val="tx1">
+                      <a:alpha val="29000"/>
+                    </a:schemeClr>
+                  </a:solidFill>
+                </a:ln>
+                <a:latin typeface="Times New Roman"/>
+                <a:ea typeface="맑은 고딕"/>
+                <a:cs typeface="Times New Roman"/>
+              </a:rPr>
+              <a:t>인품</a:t>
+            </a:r>
+          </a:p>
+        </p:txBody>
+      </p:sp>
+      <p:sp>
+        <p:nvSpPr>
+          <p:cNvPr id="10" name="TextBox 9">
+            <a:extLst>
+              <a:ext uri="{FF2B5EF4-FFF2-40B4-BE49-F238E27FC236}">
+                <a16:creationId xmlns:a16="http://schemas.microsoft.com/office/drawing/2014/main" id="{6B0947AE-2917-47B0-FB72-740CB90AD8CA}"/>
+              </a:ext>
+            </a:extLst>
+          </p:cNvPr>
+          <p:cNvSpPr txBox="1"/>
+          <p:nvPr/>
+        </p:nvSpPr>
+        <p:spPr>
+          <a:xfrm>
+            <a:off x="612743" y="1341248"/>
+            <a:ext cx="7666018" cy="1631216"/>
+          </a:xfrm>
+          <a:prstGeom prst="rect">
+            <a:avLst/>
+          </a:prstGeom>
+          <a:noFill/>
+        </p:spPr>
+        <p:txBody>
+          <a:bodyPr wrap="square" rtlCol="0">
+            <a:spAutoFit/>
+          </a:bodyPr>
+          <a:lstStyle/>
+          <a:p>
+            <a:r>
+              <a:rPr lang="ko-KR" altLang="en-US" sz="2000" dirty="0"/>
+              <a:t>장점</a:t>
+            </a:r>
+            <a:endParaRPr lang="en-US" altLang="ko-KR" sz="2000" dirty="0"/>
+          </a:p>
+          <a:p>
+            <a:pPr marL="342900" indent="-342900">
+              <a:buFont typeface="Arial" panose="020B0604020202020204" pitchFamily="34" charset="0"/>
+              <a:buChar char="•"/>
+            </a:pPr>
+            <a:r>
+              <a:rPr lang="ko-KR" altLang="ko-KR" sz="2000" dirty="0"/>
+              <a:t>개인의 성과보다 연구실의 방향과 공동체의 지속성을 우선하는 자세로 생활함.</a:t>
+            </a:r>
+            <a:endParaRPr lang="en-US" altLang="ko-KR" sz="2000" dirty="0"/>
+          </a:p>
+          <a:p>
+            <a:pPr marL="342900" indent="-342900">
+              <a:buFont typeface="Arial" panose="020B0604020202020204" pitchFamily="34" charset="0"/>
+              <a:buChar char="•"/>
+            </a:pPr>
+            <a:r>
+              <a:rPr lang="ko-KR" altLang="ko-KR" sz="2000" dirty="0"/>
+              <a:t>연구실 업무, 자료, 경험을 성실히 공유하고 인수인계 이후의 후속 질문에도 책임 있게 대응함.</a:t>
+            </a:r>
+            <a:endParaRPr lang="ko-KR" altLang="en-US" sz="2000" dirty="0">
+              <a:ln w="9525">
+                <a:solidFill>
+                  <a:schemeClr val="tx1">
+                    <a:alpha val="29000"/>
+                  </a:schemeClr>
+                </a:solidFill>
+              </a:ln>
+              <a:latin typeface="Times New Roman"/>
+              <a:ea typeface="맑은 고딕"/>
+              <a:cs typeface="Times New Roman"/>
+            </a:endParaRPr>
+          </a:p>
+        </p:txBody>
+      </p:sp>
+      <p:sp>
+        <p:nvSpPr>
+          <p:cNvPr id="4" name="TextBox 3">
+            <a:extLst>
+              <a:ext uri="{FF2B5EF4-FFF2-40B4-BE49-F238E27FC236}">
+                <a16:creationId xmlns:a16="http://schemas.microsoft.com/office/drawing/2014/main" id="{818376EF-B118-5D38-1405-5CB7B290E7C8}"/>
+              </a:ext>
+            </a:extLst>
+          </p:cNvPr>
+          <p:cNvSpPr txBox="1"/>
+          <p:nvPr/>
+        </p:nvSpPr>
+        <p:spPr>
+          <a:xfrm>
+            <a:off x="612743" y="3848799"/>
+            <a:ext cx="7666018" cy="1015663"/>
+          </a:xfrm>
+          <a:prstGeom prst="rect">
+            <a:avLst/>
+          </a:prstGeom>
+          <a:noFill/>
+        </p:spPr>
+        <p:txBody>
+          <a:bodyPr wrap="square" rtlCol="0">
+            <a:spAutoFit/>
+          </a:bodyPr>
+          <a:lstStyle/>
+          <a:p>
+            <a:r>
+              <a:rPr lang="ko-KR" altLang="en-US" sz="2000" dirty="0"/>
+              <a:t>단점</a:t>
+            </a:r>
+          </a:p>
+          <a:p>
+            <a:pPr marL="342900" indent="-342900">
+              <a:buFont typeface="Arial" panose="020B0604020202020204" pitchFamily="34" charset="0"/>
+              <a:buChar char="•"/>
+            </a:pPr>
             <a:r>
               <a:rPr lang="ko-KR" altLang="en-US" sz="2000" dirty="0">
                 <a:ln w="9525">
@@ -4520,17 +5012,82 @@
                 <a:ea typeface="맑은 고딕"/>
                 <a:cs typeface="Times New Roman"/>
               </a:rPr>
-              <a:t>인품</a:t>
-            </a:r>
-          </a:p>
-        </p:txBody>
-      </p:sp>
-      <p:sp>
-        <p:nvSpPr>
-          <p:cNvPr id="5" name="TextBox 4">
+              <a:t>연구실에 헌신하는 과정에 있어서 내가 옳다고 생각하는 방식으로 추진하려는 방향</a:t>
+            </a:r>
+          </a:p>
+        </p:txBody>
+      </p:sp>
+    </p:spTree>
+    <p:extLst>
+      <p:ext uri="{BB962C8B-B14F-4D97-AF65-F5344CB8AC3E}">
+        <p14:creationId xmlns:p14="http://schemas.microsoft.com/office/powerpoint/2010/main" val="3344830109"/>
+      </p:ext>
+    </p:extLst>
+  </p:cSld>
+  <p:clrMapOvr>
+    <a:masterClrMapping/>
+  </p:clrMapOvr>
+</p:sld>
+</file>
+
+<file path=ppt/slides/slide4.xml><?xml version="1.0" encoding="utf-8"?>
+<p:sld xmlns:a="http://schemas.openxmlformats.org/drawingml/2006/main" xmlns:r="http://schemas.openxmlformats.org/officeDocument/2006/relationships" xmlns:p="http://schemas.openxmlformats.org/presentationml/2006/main">
+  <p:cSld>
+    <p:spTree>
+      <p:nvGrpSpPr>
+        <p:cNvPr id="1" name="">
+          <a:extLst>
+            <a:ext uri="{FF2B5EF4-FFF2-40B4-BE49-F238E27FC236}">
+              <a16:creationId xmlns:a16="http://schemas.microsoft.com/office/drawing/2014/main" id="{286579A2-093A-D79A-ADB9-8558A0CC549B}"/>
+            </a:ext>
+          </a:extLst>
+        </p:cNvPr>
+        <p:cNvGrpSpPr/>
+        <p:nvPr/>
+      </p:nvGrpSpPr>
+      <p:grpSpPr>
+        <a:xfrm>
+          <a:off x="0" y="0"/>
+          <a:ext cx="0" cy="0"/>
+          <a:chOff x="0" y="0"/>
+          <a:chExt cx="0" cy="0"/>
+        </a:xfrm>
+      </p:grpSpPr>
+      <p:sp>
+        <p:nvSpPr>
+          <p:cNvPr id="2" name="슬라이드 번호 개체 틀 1">
             <a:extLst>
               <a:ext uri="{FF2B5EF4-FFF2-40B4-BE49-F238E27FC236}">
-                <a16:creationId xmlns:a16="http://schemas.microsoft.com/office/drawing/2014/main" id="{EFC0A6CD-9B46-A324-9FE6-FE536CC74B19}"/>
+                <a16:creationId xmlns:a16="http://schemas.microsoft.com/office/drawing/2014/main" id="{3713AB60-7B19-6718-4B3C-BDDA8634D9AF}"/>
+              </a:ext>
+            </a:extLst>
+          </p:cNvPr>
+          <p:cNvSpPr>
+            <a:spLocks noGrp="1"/>
+          </p:cNvSpPr>
+          <p:nvPr>
+            <p:ph type="sldNum" sz="quarter" idx="12"/>
+          </p:nvPr>
+        </p:nvSpPr>
+        <p:spPr/>
+        <p:txBody>
+          <a:bodyPr/>
+          <a:lstStyle/>
+          <a:p>
+            <a:fld id="{1F989CB1-DA8A-44BB-A4A9-D7F9352F01ED}" type="slidenum">
+              <a:rPr lang="ko-KR" altLang="en-US" smtClean="0"/>
+              <a:t>3</a:t>
+            </a:fld>
+            <a:endParaRPr lang="ko-KR" altLang="en-US"/>
+          </a:p>
+        </p:txBody>
+      </p:sp>
+      <p:sp>
+        <p:nvSpPr>
+          <p:cNvPr id="3" name="TextBox 2">
+            <a:extLst>
+              <a:ext uri="{FF2B5EF4-FFF2-40B4-BE49-F238E27FC236}">
+                <a16:creationId xmlns:a16="http://schemas.microsoft.com/office/drawing/2014/main" id="{CEF231EF-28B3-A7D7-925C-C5DBEE35DC5A}"/>
               </a:ext>
             </a:extLst>
           </p:cNvPr>
@@ -4539,8 +5096,8 @@
         </p:nvSpPr>
         <p:spPr>
           <a:xfrm>
-            <a:off x="443060" y="4278699"/>
-            <a:ext cx="2422688" cy="400110"/>
+            <a:off x="443060" y="348792"/>
+            <a:ext cx="2422688" cy="523220"/>
           </a:xfrm>
           <a:prstGeom prst="rect">
             <a:avLst/>
@@ -4554,7 +5111,7 @@
           <a:lstStyle/>
           <a:p>
             <a:r>
-              <a:rPr lang="ko-KR" altLang="en-US" sz="2000" dirty="0">
+              <a:rPr lang="ko-KR" altLang="en-US" sz="2800" dirty="0">
                 <a:ln w="9525">
                   <a:solidFill>
                     <a:schemeClr val="tx1">
@@ -4573,10 +5130,10 @@
       </p:sp>
       <p:sp>
         <p:nvSpPr>
-          <p:cNvPr id="6" name="TextBox 5">
+          <p:cNvPr id="10" name="TextBox 9">
             <a:extLst>
               <a:ext uri="{FF2B5EF4-FFF2-40B4-BE49-F238E27FC236}">
-                <a16:creationId xmlns:a16="http://schemas.microsoft.com/office/drawing/2014/main" id="{3BEEDD9A-3FD1-99D1-1751-F98B519FFE36}"/>
+                <a16:creationId xmlns:a16="http://schemas.microsoft.com/office/drawing/2014/main" id="{B4138A1C-D99F-DA48-565F-B74FD3296297}"/>
               </a:ext>
             </a:extLst>
           </p:cNvPr>
@@ -4585,8 +5142,8 @@
         </p:nvSpPr>
         <p:spPr>
           <a:xfrm>
-            <a:off x="612743" y="762513"/>
-            <a:ext cx="7666018" cy="1323439"/>
+            <a:off x="612743" y="1329672"/>
+            <a:ext cx="7666018" cy="2862322"/>
           </a:xfrm>
           <a:prstGeom prst="rect">
             <a:avLst/>
@@ -4599,53 +5156,20 @@
           </a:bodyPr>
           <a:lstStyle/>
           <a:p>
+            <a:r>
+              <a:rPr lang="ko-KR" altLang="en-US" sz="2000" dirty="0"/>
+              <a:t>맡은 바에 대한 책임감 있는 태도</a:t>
+            </a:r>
+            <a:endParaRPr lang="en-US" altLang="ko-KR" sz="2000" dirty="0"/>
+          </a:p>
+          <a:p>
             <a:pPr marL="342900" indent="-342900">
               <a:buFont typeface="Arial" panose="020B0604020202020204" pitchFamily="34" charset="0"/>
               <a:buChar char="•"/>
             </a:pPr>
             <a:r>
               <a:rPr lang="ko-KR" altLang="ko-KR" sz="2000" dirty="0"/>
-              <a:t>3-D NAND </a:t>
-            </a:r>
-            <a:r>
-              <a:rPr lang="ko-KR" altLang="ko-KR" sz="2000" dirty="0" err="1"/>
-              <a:t>Flash</a:t>
-            </a:r>
-            <a:r>
-              <a:rPr lang="ko-KR" altLang="ko-KR" sz="2000" dirty="0"/>
-              <a:t> </a:t>
-            </a:r>
-            <a:r>
-              <a:rPr lang="ko-KR" altLang="ko-KR" sz="2000" dirty="0" err="1"/>
-              <a:t>retention</a:t>
-            </a:r>
-            <a:r>
-              <a:rPr lang="ko-KR" altLang="ko-KR" sz="2000" dirty="0"/>
-              <a:t> </a:t>
-            </a:r>
-            <a:r>
-              <a:rPr lang="ko-KR" altLang="ko-KR" sz="2000" dirty="0" err="1"/>
-              <a:t>modeling</a:t>
-            </a:r>
-            <a:r>
-              <a:rPr lang="ko-KR" altLang="ko-KR" sz="2000" dirty="0"/>
-              <a:t> 연구를 수행하여 IEEE TED 및 IEEE </a:t>
-            </a:r>
-            <a:r>
-              <a:rPr lang="ko-KR" altLang="ko-KR" sz="2000" dirty="0" err="1"/>
-              <a:t>EDL에</a:t>
-            </a:r>
-            <a:r>
-              <a:rPr lang="ko-KR" altLang="ko-KR" sz="2000" dirty="0"/>
-              <a:t> 각각 </a:t>
-            </a:r>
-            <a:r>
-              <a:rPr lang="ko-KR" altLang="ko-KR" sz="2000" dirty="0" err="1"/>
-              <a:t>투고·게재함</a:t>
-            </a:r>
-            <a:r>
-              <a:rPr lang="ko-KR" altLang="ko-KR" sz="2000" dirty="0"/>
-              <a:t>.</a:t>
+              <a:t>학업과 진로에 대한 고민 속에서도 맡은 역할과 특성화대학 사업을 끝까지 수행하려는 태도를 유지함.</a:t>
             </a:r>
             <a:endParaRPr lang="en-US" altLang="ko-KR" sz="2000" dirty="0"/>
           </a:p>
@@ -4654,49 +5178,53 @@
               <a:buFont typeface="Arial" panose="020B0604020202020204" pitchFamily="34" charset="0"/>
               <a:buChar char="•"/>
             </a:pPr>
+            <a:endParaRPr lang="en-US" altLang="ko-KR" sz="2000" dirty="0"/>
+          </a:p>
+          <a:p>
+            <a:pPr marL="342900" indent="-342900">
+              <a:buFont typeface="Arial" panose="020B0604020202020204" pitchFamily="34" charset="0"/>
+              <a:buChar char="•"/>
+            </a:pPr>
+            <a:endParaRPr lang="en-US" altLang="ko-KR" sz="2000" dirty="0"/>
+          </a:p>
+          <a:p>
+            <a:pPr marL="342900" indent="-342900">
+              <a:buFont typeface="Arial" panose="020B0604020202020204" pitchFamily="34" charset="0"/>
+              <a:buChar char="•"/>
+            </a:pPr>
+            <a:endParaRPr lang="en-US" altLang="ko-KR" sz="2000" dirty="0"/>
+          </a:p>
+          <a:p>
+            <a:r>
+              <a:rPr lang="ko-KR" altLang="en-US" sz="2000" dirty="0"/>
+              <a:t>진행하는 연구에 대해서는 </a:t>
+            </a:r>
+            <a:r>
+              <a:rPr lang="ko-KR" altLang="en-US" sz="2000" dirty="0" err="1"/>
+              <a:t>타협없는</a:t>
+            </a:r>
+            <a:r>
+              <a:rPr lang="ko-KR" altLang="en-US" sz="2000" dirty="0"/>
+              <a:t> 태도</a:t>
+            </a:r>
+            <a:endParaRPr lang="en-US" altLang="ko-KR" sz="2000" dirty="0"/>
+          </a:p>
+          <a:p>
+            <a:pPr marL="342900" indent="-342900">
+              <a:buFont typeface="Arial" panose="020B0604020202020204" pitchFamily="34" charset="0"/>
+              <a:buChar char="•"/>
+            </a:pPr>
             <a:r>
               <a:rPr lang="ko-KR" altLang="ko-KR" sz="2000" dirty="0"/>
-              <a:t>TCAD </a:t>
+              <a:t>단순한 결과 </a:t>
             </a:r>
             <a:r>
               <a:rPr lang="ko-KR" altLang="ko-KR" sz="2000" dirty="0" err="1"/>
-              <a:t>simulation</a:t>
+              <a:t>fitting보다</a:t>
             </a:r>
             <a:r>
               <a:rPr lang="ko-KR" altLang="ko-KR" sz="2000" dirty="0"/>
-              <a:t>, </a:t>
-            </a:r>
-            <a:r>
-              <a:rPr lang="ko-KR" altLang="ko-KR" sz="2000" dirty="0" err="1"/>
-              <a:t>analytical</a:t>
-            </a:r>
-            <a:r>
-              <a:rPr lang="ko-KR" altLang="ko-KR" sz="2000" dirty="0"/>
-              <a:t> </a:t>
-            </a:r>
-            <a:r>
-              <a:rPr lang="ko-KR" altLang="ko-KR" sz="2000" dirty="0" err="1"/>
-              <a:t>modeling</a:t>
-            </a:r>
-            <a:r>
-              <a:rPr lang="ko-KR" altLang="ko-KR" sz="2000" dirty="0"/>
-              <a:t>, </a:t>
-            </a:r>
-            <a:r>
-              <a:rPr lang="ko-KR" altLang="ko-KR" sz="2000" dirty="0" err="1"/>
-              <a:t>device</a:t>
-            </a:r>
-            <a:r>
-              <a:rPr lang="ko-KR" altLang="ko-KR" sz="2000" dirty="0"/>
-              <a:t> </a:t>
-            </a:r>
-            <a:r>
-              <a:rPr lang="ko-KR" altLang="ko-KR" sz="2000" dirty="0" err="1"/>
-              <a:t>physics</a:t>
-            </a:r>
-            <a:r>
-              <a:rPr lang="ko-KR" altLang="ko-KR" sz="2000" dirty="0"/>
-              <a:t> 해석을 연결하여 물리 기반 모델링 역량을 입증함.</a:t>
+              <a:t> 물리적 근거와 설명 가능성을 중시하며 연구 방향을 원칙 있게 정립함.</a:t>
             </a:r>
             <a:endParaRPr lang="ko-KR" altLang="en-US" sz="2000" dirty="0">
               <a:ln w="9525">
@@ -4713,142 +5241,10 @@
           </a:p>
         </p:txBody>
       </p:sp>
-      <p:sp>
-        <p:nvSpPr>
-          <p:cNvPr id="7" name="TextBox 6">
-            <a:extLst>
-              <a:ext uri="{FF2B5EF4-FFF2-40B4-BE49-F238E27FC236}">
-                <a16:creationId xmlns:a16="http://schemas.microsoft.com/office/drawing/2014/main" id="{FB68BF02-80B1-1779-BBEF-1571982DA553}"/>
-              </a:ext>
-            </a:extLst>
-          </p:cNvPr>
-          <p:cNvSpPr txBox="1"/>
-          <p:nvPr/>
-        </p:nvSpPr>
-        <p:spPr>
-          <a:xfrm>
-            <a:off x="612743" y="2720661"/>
-            <a:ext cx="7666018" cy="1323439"/>
-          </a:xfrm>
-          <a:prstGeom prst="rect">
-            <a:avLst/>
-          </a:prstGeom>
-          <a:noFill/>
-        </p:spPr>
-        <p:txBody>
-          <a:bodyPr wrap="square" rtlCol="0">
-            <a:spAutoFit/>
-          </a:bodyPr>
-          <a:lstStyle/>
-          <a:p>
-            <a:pPr marL="342900" indent="-342900">
-              <a:buFont typeface="Arial" panose="020B0604020202020204" pitchFamily="34" charset="0"/>
-              <a:buChar char="•"/>
-            </a:pPr>
-            <a:r>
-              <a:rPr lang="ko-KR" altLang="ko-KR" sz="2000" dirty="0"/>
-              <a:t>개인의 성과보다 연구실의 방향과 공동체의 지속성을 우선하는 자세로 생활함.</a:t>
-            </a:r>
-            <a:endParaRPr lang="en-US" altLang="ko-KR" sz="2000" dirty="0"/>
-          </a:p>
-          <a:p>
-            <a:pPr marL="342900" indent="-342900">
-              <a:buFont typeface="Arial" panose="020B0604020202020204" pitchFamily="34" charset="0"/>
-              <a:buChar char="•"/>
-            </a:pPr>
-            <a:r>
-              <a:rPr lang="ko-KR" altLang="ko-KR" sz="2000" dirty="0"/>
-              <a:t>연구실 업무, 자료, 경험을 성실히 공유하고 인수인계 이후의 후속 질문에도 책임 있게 대응함.</a:t>
-            </a:r>
-            <a:endParaRPr lang="ko-KR" altLang="en-US" sz="2000" dirty="0">
-              <a:ln w="9525">
-                <a:solidFill>
-                  <a:schemeClr val="tx1">
-                    <a:alpha val="29000"/>
-                  </a:schemeClr>
-                </a:solidFill>
-              </a:ln>
-              <a:latin typeface="Times New Roman"/>
-              <a:ea typeface="맑은 고딕"/>
-              <a:cs typeface="Times New Roman"/>
-            </a:endParaRPr>
-          </a:p>
-        </p:txBody>
-      </p:sp>
-      <p:sp>
-        <p:nvSpPr>
-          <p:cNvPr id="8" name="TextBox 7">
-            <a:extLst>
-              <a:ext uri="{FF2B5EF4-FFF2-40B4-BE49-F238E27FC236}">
-                <a16:creationId xmlns:a16="http://schemas.microsoft.com/office/drawing/2014/main" id="{DF2A08EA-D9EA-89C8-ADFA-76A57C7488FD}"/>
-              </a:ext>
-            </a:extLst>
-          </p:cNvPr>
-          <p:cNvSpPr txBox="1"/>
-          <p:nvPr/>
-        </p:nvSpPr>
-        <p:spPr>
-          <a:xfrm>
-            <a:off x="612743" y="4804587"/>
-            <a:ext cx="7666018" cy="1323439"/>
-          </a:xfrm>
-          <a:prstGeom prst="rect">
-            <a:avLst/>
-          </a:prstGeom>
-          <a:noFill/>
-        </p:spPr>
-        <p:txBody>
-          <a:bodyPr wrap="square" rtlCol="0">
-            <a:spAutoFit/>
-          </a:bodyPr>
-          <a:lstStyle/>
-          <a:p>
-            <a:pPr marL="342900" indent="-342900">
-              <a:buFont typeface="Arial" panose="020B0604020202020204" pitchFamily="34" charset="0"/>
-              <a:buChar char="•"/>
-            </a:pPr>
-            <a:r>
-              <a:rPr lang="ko-KR" altLang="ko-KR" sz="2000" dirty="0"/>
-              <a:t>학업과 진로에 대한 고민 속에서도 맡은 역할과 특성화대학 사업을 끝까지 수행하려는 태도를 유지함.</a:t>
-            </a:r>
-            <a:endParaRPr lang="en-US" altLang="ko-KR" sz="2000" dirty="0"/>
-          </a:p>
-          <a:p>
-            <a:pPr marL="342900" indent="-342900">
-              <a:buFont typeface="Arial" panose="020B0604020202020204" pitchFamily="34" charset="0"/>
-              <a:buChar char="•"/>
-            </a:pPr>
-            <a:r>
-              <a:rPr lang="ko-KR" altLang="ko-KR" sz="2000" dirty="0"/>
-              <a:t>단순한 결과 </a:t>
-            </a:r>
-            <a:r>
-              <a:rPr lang="ko-KR" altLang="ko-KR" sz="2000" dirty="0" err="1"/>
-              <a:t>fitting보다</a:t>
-            </a:r>
-            <a:r>
-              <a:rPr lang="ko-KR" altLang="ko-KR" sz="2000" dirty="0"/>
-              <a:t> 물리적 근거와 설명 가능성을 중시하며 연구 방향을 원칙 있게 정립함.</a:t>
-            </a:r>
-            <a:endParaRPr lang="ko-KR" altLang="en-US" sz="2000" dirty="0">
-              <a:ln w="9525">
-                <a:solidFill>
-                  <a:schemeClr val="tx1">
-                    <a:alpha val="29000"/>
-                  </a:schemeClr>
-                </a:solidFill>
-              </a:ln>
-              <a:latin typeface="Times New Roman"/>
-              <a:ea typeface="맑은 고딕"/>
-              <a:cs typeface="Times New Roman"/>
-            </a:endParaRPr>
-          </a:p>
-        </p:txBody>
-      </p:sp>
     </p:spTree>
     <p:extLst>
       <p:ext uri="{BB962C8B-B14F-4D97-AF65-F5344CB8AC3E}">
-        <p14:creationId xmlns:p14="http://schemas.microsoft.com/office/powerpoint/2010/main" val="2735875424"/>
+        <p14:creationId xmlns:p14="http://schemas.microsoft.com/office/powerpoint/2010/main" val="900104005"/>
       </p:ext>
     </p:extLst>
   </p:cSld>

</xml_diff>